<commit_message>
9장 1, 2 4번 -  0608 수업
</commit_message>
<xml_diff>
--- a/문제해결프로그래밍_숙제/제출용/숙제9_2022182035.pptx
+++ b/문제해결프로그래밍_숙제/제출용/숙제9_2022182035.pptx
@@ -5,7 +5,7 @@
     <p:sldMasterId id="2147483670" r:id="rId1"/>
   </p:sldMasterIdLst>
   <p:notesMasterIdLst>
-    <p:notesMasterId r:id="rId9"/>
+    <p:notesMasterId r:id="rId7"/>
   </p:notesMasterIdLst>
   <p:sldIdLst>
     <p:sldId id="256" r:id="rId2"/>
@@ -13,23 +13,21 @@
     <p:sldId id="258" r:id="rId4"/>
     <p:sldId id="259" r:id="rId5"/>
     <p:sldId id="260" r:id="rId6"/>
-    <p:sldId id="261" r:id="rId7"/>
-    <p:sldId id="262" r:id="rId8"/>
   </p:sldIdLst>
   <p:sldSz cx="9144000" cy="5143500" type="screen16x9"/>
   <p:notesSz cx="6858000" cy="9144000"/>
   <p:embeddedFontLst>
     <p:embeddedFont>
       <p:font typeface="Jost" panose="020B0600000101010101" charset="0"/>
-      <p:regular r:id="rId10"/>
-      <p:bold r:id="rId11"/>
-      <p:italic r:id="rId12"/>
-      <p:boldItalic r:id="rId13"/>
+      <p:regular r:id="rId8"/>
+      <p:bold r:id="rId9"/>
+      <p:italic r:id="rId10"/>
+      <p:boldItalic r:id="rId11"/>
     </p:embeddedFont>
     <p:embeddedFont>
       <p:font typeface="Palanquin Dark" panose="020B0600000101010101" charset="0"/>
-      <p:regular r:id="rId14"/>
-      <p:bold r:id="rId15"/>
+      <p:regular r:id="rId12"/>
+      <p:bold r:id="rId13"/>
     </p:embeddedFont>
   </p:embeddedFontLst>
   <p:defaultTextStyle>
@@ -1324,260 +1322,6 @@
     <p:extLst>
       <p:ext uri="{BB962C8B-B14F-4D97-AF65-F5344CB8AC3E}">
         <p14:creationId xmlns:p14="http://schemas.microsoft.com/office/powerpoint/2010/main" val="682162643"/>
-      </p:ext>
-    </p:extLst>
-  </p:cSld>
-  <p:clrMapOvr>
-    <a:masterClrMapping/>
-  </p:clrMapOvr>
-</p:notes>
-</file>
-
-<file path=ppt/notesSlides/notesSlide6.xml><?xml version="1.0" encoding="utf-8"?>
-<p:notes xmlns:a="http://schemas.openxmlformats.org/drawingml/2006/main" xmlns:r="http://schemas.openxmlformats.org/officeDocument/2006/relationships" xmlns:p="http://schemas.openxmlformats.org/presentationml/2006/main" showMasterSp="0" showMasterPhAnim="0">
-  <p:cSld>
-    <p:spTree>
-      <p:nvGrpSpPr>
-        <p:cNvPr id="1" name="Shape 431">
-          <a:extLst>
-            <a:ext uri="{FF2B5EF4-FFF2-40B4-BE49-F238E27FC236}">
-              <a16:creationId xmlns:a16="http://schemas.microsoft.com/office/drawing/2014/main" id="{A651A226-C7E1-9E92-77E2-57EB51B57075}"/>
-            </a:ext>
-          </a:extLst>
-        </p:cNvPr>
-        <p:cNvGrpSpPr/>
-        <p:nvPr/>
-      </p:nvGrpSpPr>
-      <p:grpSpPr>
-        <a:xfrm>
-          <a:off x="0" y="0"/>
-          <a:ext cx="0" cy="0"/>
-          <a:chOff x="0" y="0"/>
-          <a:chExt cx="0" cy="0"/>
-        </a:xfrm>
-      </p:grpSpPr>
-      <p:sp>
-        <p:nvSpPr>
-          <p:cNvPr id="432" name="Google Shape;432;g3cf4798b604_0_426:notes">
-            <a:extLst>
-              <a:ext uri="{FF2B5EF4-FFF2-40B4-BE49-F238E27FC236}">
-                <a16:creationId xmlns:a16="http://schemas.microsoft.com/office/drawing/2014/main" id="{6B49EDD2-FA63-262B-3BC4-F21A26EED380}"/>
-              </a:ext>
-            </a:extLst>
-          </p:cNvPr>
-          <p:cNvSpPr>
-            <a:spLocks noGrp="1" noRot="1" noChangeAspect="1"/>
-          </p:cNvSpPr>
-          <p:nvPr>
-            <p:ph type="sldImg" idx="2"/>
-          </p:nvPr>
-        </p:nvSpPr>
-        <p:spPr>
-          <a:xfrm>
-            <a:off x="381000" y="685800"/>
-            <a:ext cx="6096000" cy="3429000"/>
-          </a:xfrm>
-          <a:custGeom>
-            <a:avLst/>
-            <a:gdLst/>
-            <a:ahLst/>
-            <a:cxnLst/>
-            <a:rect l="l" t="t" r="r" b="b"/>
-            <a:pathLst>
-              <a:path w="120000" h="120000" extrusionOk="0">
-                <a:moveTo>
-                  <a:pt x="0" y="0"/>
-                </a:moveTo>
-                <a:lnTo>
-                  <a:pt x="120000" y="0"/>
-                </a:lnTo>
-                <a:lnTo>
-                  <a:pt x="120000" y="120000"/>
-                </a:lnTo>
-                <a:lnTo>
-                  <a:pt x="0" y="120000"/>
-                </a:lnTo>
-                <a:close/>
-              </a:path>
-            </a:pathLst>
-          </a:custGeom>
-        </p:spPr>
-      </p:sp>
-      <p:sp>
-        <p:nvSpPr>
-          <p:cNvPr id="433" name="Google Shape;433;g3cf4798b604_0_426:notes">
-            <a:extLst>
-              <a:ext uri="{FF2B5EF4-FFF2-40B4-BE49-F238E27FC236}">
-                <a16:creationId xmlns:a16="http://schemas.microsoft.com/office/drawing/2014/main" id="{A0ACBD59-3151-20CC-5F31-CF20ACD3A8F4}"/>
-              </a:ext>
-            </a:extLst>
-          </p:cNvPr>
-          <p:cNvSpPr txBox="1">
-            <a:spLocks noGrp="1"/>
-          </p:cNvSpPr>
-          <p:nvPr>
-            <p:ph type="body" idx="1"/>
-          </p:nvPr>
-        </p:nvSpPr>
-        <p:spPr>
-          <a:xfrm>
-            <a:off x="685800" y="4343400"/>
-            <a:ext cx="5486400" cy="4114800"/>
-          </a:xfrm>
-          <a:prstGeom prst="rect">
-            <a:avLst/>
-          </a:prstGeom>
-        </p:spPr>
-        <p:txBody>
-          <a:bodyPr spcFirstLastPara="1" wrap="square" lIns="91425" tIns="91425" rIns="91425" bIns="91425" anchor="t" anchorCtr="0">
-            <a:noAutofit/>
-          </a:bodyPr>
-          <a:lstStyle/>
-          <a:p>
-            <a:pPr marL="0" lvl="0" indent="0" algn="l" rtl="0">
-              <a:spcBef>
-                <a:spcPts val="0"/>
-              </a:spcBef>
-              <a:spcAft>
-                <a:spcPts val="0"/>
-              </a:spcAft>
-              <a:buNone/>
-            </a:pPr>
-            <a:endParaRPr/>
-          </a:p>
-        </p:txBody>
-      </p:sp>
-    </p:spTree>
-    <p:extLst>
-      <p:ext uri="{BB962C8B-B14F-4D97-AF65-F5344CB8AC3E}">
-        <p14:creationId xmlns:p14="http://schemas.microsoft.com/office/powerpoint/2010/main" val="362914310"/>
-      </p:ext>
-    </p:extLst>
-  </p:cSld>
-  <p:clrMapOvr>
-    <a:masterClrMapping/>
-  </p:clrMapOvr>
-</p:notes>
-</file>
-
-<file path=ppt/notesSlides/notesSlide7.xml><?xml version="1.0" encoding="utf-8"?>
-<p:notes xmlns:a="http://schemas.openxmlformats.org/drawingml/2006/main" xmlns:r="http://schemas.openxmlformats.org/officeDocument/2006/relationships" xmlns:p="http://schemas.openxmlformats.org/presentationml/2006/main" showMasterSp="0" showMasterPhAnim="0">
-  <p:cSld>
-    <p:spTree>
-      <p:nvGrpSpPr>
-        <p:cNvPr id="1" name="Shape 431">
-          <a:extLst>
-            <a:ext uri="{FF2B5EF4-FFF2-40B4-BE49-F238E27FC236}">
-              <a16:creationId xmlns:a16="http://schemas.microsoft.com/office/drawing/2014/main" id="{E35CB906-B1C7-1EBE-8058-7B9F28563C2F}"/>
-            </a:ext>
-          </a:extLst>
-        </p:cNvPr>
-        <p:cNvGrpSpPr/>
-        <p:nvPr/>
-      </p:nvGrpSpPr>
-      <p:grpSpPr>
-        <a:xfrm>
-          <a:off x="0" y="0"/>
-          <a:ext cx="0" cy="0"/>
-          <a:chOff x="0" y="0"/>
-          <a:chExt cx="0" cy="0"/>
-        </a:xfrm>
-      </p:grpSpPr>
-      <p:sp>
-        <p:nvSpPr>
-          <p:cNvPr id="432" name="Google Shape;432;g3cf4798b604_0_426:notes">
-            <a:extLst>
-              <a:ext uri="{FF2B5EF4-FFF2-40B4-BE49-F238E27FC236}">
-                <a16:creationId xmlns:a16="http://schemas.microsoft.com/office/drawing/2014/main" id="{74C03AAF-F486-7973-7E95-5875AA5881C8}"/>
-              </a:ext>
-            </a:extLst>
-          </p:cNvPr>
-          <p:cNvSpPr>
-            <a:spLocks noGrp="1" noRot="1" noChangeAspect="1"/>
-          </p:cNvSpPr>
-          <p:nvPr>
-            <p:ph type="sldImg" idx="2"/>
-          </p:nvPr>
-        </p:nvSpPr>
-        <p:spPr>
-          <a:xfrm>
-            <a:off x="381000" y="685800"/>
-            <a:ext cx="6096000" cy="3429000"/>
-          </a:xfrm>
-          <a:custGeom>
-            <a:avLst/>
-            <a:gdLst/>
-            <a:ahLst/>
-            <a:cxnLst/>
-            <a:rect l="l" t="t" r="r" b="b"/>
-            <a:pathLst>
-              <a:path w="120000" h="120000" extrusionOk="0">
-                <a:moveTo>
-                  <a:pt x="0" y="0"/>
-                </a:moveTo>
-                <a:lnTo>
-                  <a:pt x="120000" y="0"/>
-                </a:lnTo>
-                <a:lnTo>
-                  <a:pt x="120000" y="120000"/>
-                </a:lnTo>
-                <a:lnTo>
-                  <a:pt x="0" y="120000"/>
-                </a:lnTo>
-                <a:close/>
-              </a:path>
-            </a:pathLst>
-          </a:custGeom>
-        </p:spPr>
-      </p:sp>
-      <p:sp>
-        <p:nvSpPr>
-          <p:cNvPr id="433" name="Google Shape;433;g3cf4798b604_0_426:notes">
-            <a:extLst>
-              <a:ext uri="{FF2B5EF4-FFF2-40B4-BE49-F238E27FC236}">
-                <a16:creationId xmlns:a16="http://schemas.microsoft.com/office/drawing/2014/main" id="{2CF0D1AA-9EAF-88F1-05B6-E556B486D936}"/>
-              </a:ext>
-            </a:extLst>
-          </p:cNvPr>
-          <p:cNvSpPr txBox="1">
-            <a:spLocks noGrp="1"/>
-          </p:cNvSpPr>
-          <p:nvPr>
-            <p:ph type="body" idx="1"/>
-          </p:nvPr>
-        </p:nvSpPr>
-        <p:spPr>
-          <a:xfrm>
-            <a:off x="685800" y="4343400"/>
-            <a:ext cx="5486400" cy="4114800"/>
-          </a:xfrm>
-          <a:prstGeom prst="rect">
-            <a:avLst/>
-          </a:prstGeom>
-        </p:spPr>
-        <p:txBody>
-          <a:bodyPr spcFirstLastPara="1" wrap="square" lIns="91425" tIns="91425" rIns="91425" bIns="91425" anchor="t" anchorCtr="0">
-            <a:noAutofit/>
-          </a:bodyPr>
-          <a:lstStyle/>
-          <a:p>
-            <a:pPr marL="0" lvl="0" indent="0" algn="l" rtl="0">
-              <a:spcBef>
-                <a:spcPts val="0"/>
-              </a:spcBef>
-              <a:spcAft>
-                <a:spcPts val="0"/>
-              </a:spcAft>
-              <a:buNone/>
-            </a:pPr>
-            <a:endParaRPr/>
-          </a:p>
-        </p:txBody>
-      </p:sp>
-    </p:spTree>
-    <p:extLst>
-      <p:ext uri="{BB962C8B-B14F-4D97-AF65-F5344CB8AC3E}">
-        <p14:creationId xmlns:p14="http://schemas.microsoft.com/office/powerpoint/2010/main" val="2067769389"/>
       </p:ext>
     </p:extLst>
   </p:cSld>
@@ -34172,20 +33916,113 @@
           </a:bodyPr>
           <a:lstStyle/>
           <a:p>
-            <a:pPr marL="457200" lvl="0" indent="-406400" algn="ctr" rtl="0">
-              <a:spcBef>
-                <a:spcPts val="0"/>
-              </a:spcBef>
-              <a:spcAft>
-                <a:spcPts val="0"/>
-              </a:spcAft>
-              <a:buSzPts val="2800"/>
+            <a:pPr marL="457200" lvl="0" indent="-406400">
               <a:buAutoNum type="arabicPeriod"/>
             </a:pPr>
+            <a:r>
+              <a:rPr lang="ko-KR" altLang="en-US" dirty="0"/>
+              <a:t>두 수의 합 </a:t>
+            </a:r>
+            <a:r>
+              <a:rPr lang="en-US" altLang="ko-KR" dirty="0"/>
+              <a:t>(</a:t>
+            </a:r>
+            <a:r>
+              <a:rPr lang="en-US" altLang="ko-KR" dirty="0" err="1"/>
+              <a:t>TUKorea</a:t>
+            </a:r>
+            <a:r>
+              <a:rPr lang="en-US" altLang="ko-KR" dirty="0"/>
+              <a:t>, </a:t>
+            </a:r>
+            <a:r>
+              <a:rPr lang="ko-KR" altLang="en-US" dirty="0"/>
+              <a:t>백준</a:t>
+            </a:r>
+            <a:r>
+              <a:rPr lang="en-US" altLang="ko-KR" dirty="0"/>
+              <a:t>, </a:t>
+            </a:r>
+            <a:r>
+              <a:rPr lang="ko-KR" altLang="en-US" dirty="0" err="1"/>
+              <a:t>투포인터</a:t>
+            </a:r>
+            <a:r>
+              <a:rPr lang="en-US" altLang="ko-KR" dirty="0"/>
+              <a:t>, </a:t>
+            </a:r>
+            <a:r>
+              <a:rPr lang="ko-KR" altLang="en-US" dirty="0"/>
+              <a:t>정렬</a:t>
+            </a:r>
+            <a:r>
+              <a:rPr lang="en-US" altLang="ko-KR" dirty="0"/>
+              <a:t>)</a:t>
+            </a:r>
             <a:endParaRPr dirty="0"/>
           </a:p>
         </p:txBody>
       </p:sp>
+      <p:pic>
+        <p:nvPicPr>
+          <p:cNvPr id="3" name="그림 2">
+            <a:extLst>
+              <a:ext uri="{FF2B5EF4-FFF2-40B4-BE49-F238E27FC236}">
+                <a16:creationId xmlns:a16="http://schemas.microsoft.com/office/drawing/2014/main" id="{5946A35A-255E-14D9-DA52-7DDF717D065C}"/>
+              </a:ext>
+            </a:extLst>
+          </p:cNvPr>
+          <p:cNvPicPr>
+            <a:picLocks noChangeAspect="1"/>
+          </p:cNvPicPr>
+          <p:nvPr/>
+        </p:nvPicPr>
+        <p:blipFill>
+          <a:blip r:embed="rId3"/>
+          <a:stretch>
+            <a:fillRect/>
+          </a:stretch>
+        </p:blipFill>
+        <p:spPr>
+          <a:xfrm>
+            <a:off x="426662" y="1337352"/>
+            <a:ext cx="2581714" cy="3264408"/>
+          </a:xfrm>
+          <a:prstGeom prst="rect">
+            <a:avLst/>
+          </a:prstGeom>
+        </p:spPr>
+      </p:pic>
+      <p:pic>
+        <p:nvPicPr>
+          <p:cNvPr id="5" name="그림 4">
+            <a:extLst>
+              <a:ext uri="{FF2B5EF4-FFF2-40B4-BE49-F238E27FC236}">
+                <a16:creationId xmlns:a16="http://schemas.microsoft.com/office/drawing/2014/main" id="{2ABA7E04-F2C3-E6B4-6CCA-6280E924B069}"/>
+              </a:ext>
+            </a:extLst>
+          </p:cNvPr>
+          <p:cNvPicPr>
+            <a:picLocks noChangeAspect="1"/>
+          </p:cNvPicPr>
+          <p:nvPr/>
+        </p:nvPicPr>
+        <p:blipFill>
+          <a:blip r:embed="rId4"/>
+          <a:stretch>
+            <a:fillRect/>
+          </a:stretch>
+        </p:blipFill>
+        <p:spPr>
+          <a:xfrm>
+            <a:off x="3057202" y="2338535"/>
+            <a:ext cx="5660136" cy="795613"/>
+          </a:xfrm>
+          <a:prstGeom prst="rect">
+            <a:avLst/>
+          </a:prstGeom>
+        </p:spPr>
+      </p:pic>
     </p:spTree>
   </p:cSld>
   <p:clrMapOvr>
@@ -34248,23 +34085,81 @@
           </a:bodyPr>
           <a:lstStyle/>
           <a:p>
-            <a:pPr marL="50800" lvl="0" algn="ctr" rtl="0">
-              <a:spcBef>
-                <a:spcPts val="0"/>
-              </a:spcBef>
-              <a:spcAft>
-                <a:spcPts val="0"/>
-              </a:spcAft>
-              <a:buSzPts val="2800"/>
-            </a:pPr>
+            <a:pPr marL="50800" lvl="0"/>
             <a:r>
               <a:rPr lang="en-US" dirty="0"/>
               <a:t>2. </a:t>
+            </a:r>
+            <a:r>
+              <a:rPr lang="ko-KR" altLang="en-US" sz="4000" dirty="0" err="1"/>
+              <a:t>소수회문</a:t>
+            </a:r>
+            <a:r>
+              <a:rPr lang="ko-KR" altLang="en-US" sz="4000" dirty="0"/>
+              <a:t> </a:t>
+            </a:r>
+            <a:r>
+              <a:rPr lang="en-US" altLang="ko-KR" sz="4000" dirty="0"/>
+              <a:t>(</a:t>
+            </a:r>
+            <a:r>
+              <a:rPr lang="en-US" altLang="ko-KR" sz="4000" dirty="0" err="1"/>
+              <a:t>TUKorea</a:t>
+            </a:r>
+            <a:r>
+              <a:rPr lang="en-US" altLang="ko-KR" sz="4000" dirty="0"/>
+              <a:t>, </a:t>
+            </a:r>
+            <a:r>
+              <a:rPr lang="ko-KR" altLang="en-US" sz="4000" dirty="0"/>
+              <a:t>소수</a:t>
+            </a:r>
+            <a:r>
+              <a:rPr lang="en-US" altLang="ko-KR" sz="4000" dirty="0"/>
+              <a:t>, </a:t>
+            </a:r>
+            <a:r>
+              <a:rPr lang="ko-KR" altLang="en-US" sz="4000" dirty="0"/>
+              <a:t>구현</a:t>
+            </a:r>
+            <a:r>
+              <a:rPr lang="en-US" altLang="ko-KR" sz="4000" dirty="0"/>
+              <a:t>)</a:t>
             </a:r>
             <a:endParaRPr dirty="0"/>
           </a:p>
         </p:txBody>
       </p:sp>
+      <p:pic>
+        <p:nvPicPr>
+          <p:cNvPr id="3" name="그림 2">
+            <a:extLst>
+              <a:ext uri="{FF2B5EF4-FFF2-40B4-BE49-F238E27FC236}">
+                <a16:creationId xmlns:a16="http://schemas.microsoft.com/office/drawing/2014/main" id="{BC3FD8DC-ACB5-2028-AD40-88B919EEB764}"/>
+              </a:ext>
+            </a:extLst>
+          </p:cNvPr>
+          <p:cNvPicPr>
+            <a:picLocks noChangeAspect="1"/>
+          </p:cNvPicPr>
+          <p:nvPr/>
+        </p:nvPicPr>
+        <p:blipFill>
+          <a:blip r:embed="rId3"/>
+          <a:stretch>
+            <a:fillRect/>
+          </a:stretch>
+        </p:blipFill>
+        <p:spPr>
+          <a:xfrm>
+            <a:off x="1316724" y="1196095"/>
+            <a:ext cx="6510528" cy="3365207"/>
+          </a:xfrm>
+          <a:prstGeom prst="rect">
+            <a:avLst/>
+          </a:prstGeom>
+        </p:spPr>
+      </p:pic>
     </p:spTree>
     <p:extLst>
       <p:ext uri="{BB962C8B-B14F-4D97-AF65-F5344CB8AC3E}">
@@ -34416,23 +34311,111 @@
           </a:bodyPr>
           <a:lstStyle/>
           <a:p>
-            <a:pPr marL="50800" lvl="0" algn="ctr" rtl="0">
-              <a:spcBef>
-                <a:spcPts val="0"/>
-              </a:spcBef>
-              <a:spcAft>
-                <a:spcPts val="0"/>
-              </a:spcAft>
-              <a:buSzPts val="2800"/>
-            </a:pPr>
+            <a:pPr marL="50800" lvl="0"/>
             <a:r>
               <a:rPr lang="en-US" dirty="0"/>
               <a:t>4. </a:t>
+            </a:r>
+            <a:r>
+              <a:rPr lang="ko-KR" altLang="en-US" dirty="0"/>
+              <a:t>목재 총량</a:t>
+            </a:r>
+            <a:r>
+              <a:rPr lang="en-US" dirty="0"/>
+              <a:t> </a:t>
+            </a:r>
+            <a:r>
+              <a:rPr lang="en-US" altLang="ko-KR" dirty="0"/>
+              <a:t>(</a:t>
+            </a:r>
+            <a:r>
+              <a:rPr lang="en-US" altLang="ko-KR" dirty="0" err="1"/>
+              <a:t>TUKorea</a:t>
+            </a:r>
+            <a:r>
+              <a:rPr lang="en-US" altLang="ko-KR" dirty="0"/>
+              <a:t>, </a:t>
+            </a:r>
+            <a:r>
+              <a:rPr lang="ko-KR" altLang="en-US" dirty="0"/>
+              <a:t>백준</a:t>
+            </a:r>
+            <a:r>
+              <a:rPr lang="en-US" altLang="ko-KR" dirty="0"/>
+              <a:t>, </a:t>
+            </a:r>
+            <a:r>
+              <a:rPr lang="ko-KR" altLang="en-US" dirty="0" err="1"/>
+              <a:t>누적합</a:t>
+            </a:r>
+            <a:r>
+              <a:rPr lang="en-US" altLang="ko-KR" dirty="0"/>
+              <a:t>, DP)</a:t>
             </a:r>
             <a:endParaRPr dirty="0"/>
           </a:p>
         </p:txBody>
       </p:sp>
+      <p:pic>
+        <p:nvPicPr>
+          <p:cNvPr id="3" name="그림 2">
+            <a:extLst>
+              <a:ext uri="{FF2B5EF4-FFF2-40B4-BE49-F238E27FC236}">
+                <a16:creationId xmlns:a16="http://schemas.microsoft.com/office/drawing/2014/main" id="{B077CCC9-2ABA-8AF2-A856-6201C313952B}"/>
+              </a:ext>
+            </a:extLst>
+          </p:cNvPr>
+          <p:cNvPicPr>
+            <a:picLocks noChangeAspect="1"/>
+          </p:cNvPicPr>
+          <p:nvPr/>
+        </p:nvPicPr>
+        <p:blipFill>
+          <a:blip r:embed="rId3"/>
+          <a:stretch>
+            <a:fillRect/>
+          </a:stretch>
+        </p:blipFill>
+        <p:spPr>
+          <a:xfrm>
+            <a:off x="3197693" y="1710602"/>
+            <a:ext cx="5349276" cy="1722295"/>
+          </a:xfrm>
+          <a:prstGeom prst="rect">
+            <a:avLst/>
+          </a:prstGeom>
+        </p:spPr>
+      </p:pic>
+      <p:pic>
+        <p:nvPicPr>
+          <p:cNvPr id="5" name="그림 4">
+            <a:extLst>
+              <a:ext uri="{FF2B5EF4-FFF2-40B4-BE49-F238E27FC236}">
+                <a16:creationId xmlns:a16="http://schemas.microsoft.com/office/drawing/2014/main" id="{5918A6F8-667A-E341-3DCB-E9707C084BD7}"/>
+              </a:ext>
+            </a:extLst>
+          </p:cNvPr>
+          <p:cNvPicPr>
+            <a:picLocks noChangeAspect="1"/>
+          </p:cNvPicPr>
+          <p:nvPr/>
+        </p:nvPicPr>
+        <p:blipFill>
+          <a:blip r:embed="rId4"/>
+          <a:stretch>
+            <a:fillRect/>
+          </a:stretch>
+        </p:blipFill>
+        <p:spPr>
+          <a:xfrm>
+            <a:off x="597031" y="997911"/>
+            <a:ext cx="2295009" cy="3611880"/>
+          </a:xfrm>
+          <a:prstGeom prst="rect">
+            <a:avLst/>
+          </a:prstGeom>
+        </p:spPr>
+      </p:pic>
     </p:spTree>
     <p:extLst>
       <p:ext uri="{BB962C8B-B14F-4D97-AF65-F5344CB8AC3E}">
@@ -34521,174 +34504,6 @@
     <p:extLst>
       <p:ext uri="{BB962C8B-B14F-4D97-AF65-F5344CB8AC3E}">
         <p14:creationId xmlns:p14="http://schemas.microsoft.com/office/powerpoint/2010/main" val="817275800"/>
-      </p:ext>
-    </p:extLst>
-  </p:cSld>
-  <p:clrMapOvr>
-    <a:masterClrMapping/>
-  </p:clrMapOvr>
-</p:sld>
-</file>
-
-<file path=ppt/slides/slide6.xml><?xml version="1.0" encoding="utf-8"?>
-<p:sld xmlns:a="http://schemas.openxmlformats.org/drawingml/2006/main" xmlns:r="http://schemas.openxmlformats.org/officeDocument/2006/relationships" xmlns:p="http://schemas.openxmlformats.org/presentationml/2006/main">
-  <p:cSld>
-    <p:spTree>
-      <p:nvGrpSpPr>
-        <p:cNvPr id="1" name="Shape 434">
-          <a:extLst>
-            <a:ext uri="{FF2B5EF4-FFF2-40B4-BE49-F238E27FC236}">
-              <a16:creationId xmlns:a16="http://schemas.microsoft.com/office/drawing/2014/main" id="{C49BA4F5-64A4-80A1-8EEF-D567FBAA9007}"/>
-            </a:ext>
-          </a:extLst>
-        </p:cNvPr>
-        <p:cNvGrpSpPr/>
-        <p:nvPr/>
-      </p:nvGrpSpPr>
-      <p:grpSpPr>
-        <a:xfrm>
-          <a:off x="0" y="0"/>
-          <a:ext cx="0" cy="0"/>
-          <a:chOff x="0" y="0"/>
-          <a:chExt cx="0" cy="0"/>
-        </a:xfrm>
-      </p:grpSpPr>
-      <p:sp>
-        <p:nvSpPr>
-          <p:cNvPr id="435" name="Google Shape;435;p24">
-            <a:extLst>
-              <a:ext uri="{FF2B5EF4-FFF2-40B4-BE49-F238E27FC236}">
-                <a16:creationId xmlns:a16="http://schemas.microsoft.com/office/drawing/2014/main" id="{22CEDD2E-D36E-1AD0-B231-8D45A4F97B7E}"/>
-              </a:ext>
-            </a:extLst>
-          </p:cNvPr>
-          <p:cNvSpPr txBox="1">
-            <a:spLocks noGrp="1"/>
-          </p:cNvSpPr>
-          <p:nvPr>
-            <p:ph type="title"/>
-          </p:nvPr>
-        </p:nvSpPr>
-        <p:spPr>
-          <a:xfrm>
-            <a:off x="722388" y="362600"/>
-            <a:ext cx="7699200" cy="572700"/>
-          </a:xfrm>
-          <a:prstGeom prst="rect">
-            <a:avLst/>
-          </a:prstGeom>
-        </p:spPr>
-        <p:txBody>
-          <a:bodyPr spcFirstLastPara="1" wrap="square" lIns="91425" tIns="91425" rIns="91425" bIns="91425" anchor="t" anchorCtr="0">
-            <a:noAutofit/>
-          </a:bodyPr>
-          <a:lstStyle/>
-          <a:p>
-            <a:pPr marL="50800" lvl="0" algn="ctr" rtl="0">
-              <a:spcBef>
-                <a:spcPts val="0"/>
-              </a:spcBef>
-              <a:spcAft>
-                <a:spcPts val="0"/>
-              </a:spcAft>
-              <a:buSzPts val="2800"/>
-            </a:pPr>
-            <a:r>
-              <a:rPr lang="en-US" dirty="0"/>
-              <a:t>6. </a:t>
-            </a:r>
-            <a:endParaRPr dirty="0"/>
-          </a:p>
-        </p:txBody>
-      </p:sp>
-    </p:spTree>
-    <p:extLst>
-      <p:ext uri="{BB962C8B-B14F-4D97-AF65-F5344CB8AC3E}">
-        <p14:creationId xmlns:p14="http://schemas.microsoft.com/office/powerpoint/2010/main" val="2934289483"/>
-      </p:ext>
-    </p:extLst>
-  </p:cSld>
-  <p:clrMapOvr>
-    <a:masterClrMapping/>
-  </p:clrMapOvr>
-</p:sld>
-</file>
-
-<file path=ppt/slides/slide7.xml><?xml version="1.0" encoding="utf-8"?>
-<p:sld xmlns:a="http://schemas.openxmlformats.org/drawingml/2006/main" xmlns:r="http://schemas.openxmlformats.org/officeDocument/2006/relationships" xmlns:p="http://schemas.openxmlformats.org/presentationml/2006/main">
-  <p:cSld>
-    <p:spTree>
-      <p:nvGrpSpPr>
-        <p:cNvPr id="1" name="Shape 434">
-          <a:extLst>
-            <a:ext uri="{FF2B5EF4-FFF2-40B4-BE49-F238E27FC236}">
-              <a16:creationId xmlns:a16="http://schemas.microsoft.com/office/drawing/2014/main" id="{28A818DE-ADEE-A871-1CAA-DD3118DC9E45}"/>
-            </a:ext>
-          </a:extLst>
-        </p:cNvPr>
-        <p:cNvGrpSpPr/>
-        <p:nvPr/>
-      </p:nvGrpSpPr>
-      <p:grpSpPr>
-        <a:xfrm>
-          <a:off x="0" y="0"/>
-          <a:ext cx="0" cy="0"/>
-          <a:chOff x="0" y="0"/>
-          <a:chExt cx="0" cy="0"/>
-        </a:xfrm>
-      </p:grpSpPr>
-      <p:sp>
-        <p:nvSpPr>
-          <p:cNvPr id="435" name="Google Shape;435;p24">
-            <a:extLst>
-              <a:ext uri="{FF2B5EF4-FFF2-40B4-BE49-F238E27FC236}">
-                <a16:creationId xmlns:a16="http://schemas.microsoft.com/office/drawing/2014/main" id="{90F1BF5E-8C4F-D989-24DF-95799A92E8BD}"/>
-              </a:ext>
-            </a:extLst>
-          </p:cNvPr>
-          <p:cNvSpPr txBox="1">
-            <a:spLocks noGrp="1"/>
-          </p:cNvSpPr>
-          <p:nvPr>
-            <p:ph type="title"/>
-          </p:nvPr>
-        </p:nvSpPr>
-        <p:spPr>
-          <a:xfrm>
-            <a:off x="722388" y="362600"/>
-            <a:ext cx="7699200" cy="572700"/>
-          </a:xfrm>
-          <a:prstGeom prst="rect">
-            <a:avLst/>
-          </a:prstGeom>
-        </p:spPr>
-        <p:txBody>
-          <a:bodyPr spcFirstLastPara="1" wrap="square" lIns="91425" tIns="91425" rIns="91425" bIns="91425" anchor="t" anchorCtr="0">
-            <a:noAutofit/>
-          </a:bodyPr>
-          <a:lstStyle/>
-          <a:p>
-            <a:pPr marL="50800" lvl="0" algn="ctr" rtl="0">
-              <a:spcBef>
-                <a:spcPts val="0"/>
-              </a:spcBef>
-              <a:spcAft>
-                <a:spcPts val="0"/>
-              </a:spcAft>
-              <a:buSzPts val="2800"/>
-            </a:pPr>
-            <a:r>
-              <a:rPr lang="en-US" dirty="0"/>
-              <a:t>7. </a:t>
-            </a:r>
-            <a:endParaRPr dirty="0"/>
-          </a:p>
-        </p:txBody>
-      </p:sp>
-    </p:spTree>
-    <p:extLst>
-      <p:ext uri="{BB962C8B-B14F-4D97-AF65-F5344CB8AC3E}">
-        <p14:creationId xmlns:p14="http://schemas.microsoft.com/office/powerpoint/2010/main" val="1305028121"/>
       </p:ext>
     </p:extLst>
   </p:cSld>

</xml_diff>